<commit_message>
fix(presentations): harden PPTX v2 cutover [ODMROZENIE 11_MATERIALS DEC-543]
</commit_message>
<xml_diff>
--- a/docs/program/EXPORT_1_STAGE2_20260916/dowody/deck-builder-export.pptx
+++ b/docs/program/EXPORT_1_STAGE2_20260916/dowody/deck-builder-export.pptx
@@ -1146,7 +1146,7 @@
                   <a:srgbClr val="FFFFFF"/>
                 </a:solidFill>
               </a:rPr>
-              <a:t>Northwind Q3 Steering Deck</a:t>
+              <a:t>Atelier Forward — Board Readout</a:t>
             </a:r>
             <a:endParaRPr lang="en-US" sz="3100" dirty="0"/>
           </a:p>
@@ -1205,7 +1205,7 @@
                   <a:srgbClr val="C8D4E6"/>
                 </a:solidFill>
               </a:rPr>
-              <a:t>A focused plan to recover delivery confidence</a:t>
+              <a:t>A focused decision brief for the next operating cycle</a:t>
             </a:r>
             <a:endParaRPr lang="en-US" sz="1100" dirty="0"/>
           </a:p>
@@ -1421,7 +1421,7 @@
                   <a:srgbClr val="1B2A41"/>
                 </a:solidFill>
               </a:rPr>
-              <a:t>Recovery is measurable</a:t>
+              <a:t>What changed</a:t>
             </a:r>
             <a:endParaRPr lang="en-US" sz="2100" dirty="0"/>
           </a:p>
@@ -1482,7 +1482,7 @@
                   <a:srgbClr val="101828"/>
                 </a:solidFill>
               </a:rPr>
-              <a:t>Protect the committed customer milestones</a:t>
+              <a:t>Demand is concentrated in two priority segments.</a:t>
             </a:r>
             <a:endParaRPr lang="en-US" sz="1200" dirty="0"/>
           </a:p>
@@ -1496,7 +1496,7 @@
                   <a:srgbClr val="101828"/>
                 </a:solidFill>
               </a:rPr>
-              <a:t>Measure weekly capacity by person</a:t>
+              <a:t>Delivery reliability improved while quality held.</a:t>
             </a:r>
             <a:endParaRPr lang="en-US" sz="1200" dirty="0"/>
           </a:p>
@@ -1510,7 +1510,91 @@
                   <a:srgbClr val="101828"/>
                 </a:solidFill>
               </a:rPr>
-              <a:t>Escalate blockers with named owners</a:t>
+              <a:t>The next gate requires an accountable owner.</a:t>
+            </a:r>
+            <a:endParaRPr lang="en-US" sz="1200" dirty="0"/>
+          </a:p>
+          <a:p>
+            <a:pPr indent="0" marL="0">
+              <a:buNone/>
+            </a:pPr>
+            <a:r>
+              <a:rPr lang="en-US" sz="1200" dirty="0">
+                <a:solidFill>
+                  <a:srgbClr val="101828"/>
+                </a:solidFill>
+              </a:rPr>
+              <a:t>Measure</a:t>
+            </a:r>
+            <a:endParaRPr lang="en-US" sz="1200" dirty="0"/>
+          </a:p>
+          <a:p>
+            <a:pPr indent="0" marL="0">
+              <a:buNone/>
+            </a:pPr>
+            <a:r>
+              <a:rPr lang="en-US" sz="1200" dirty="0">
+                <a:solidFill>
+                  <a:srgbClr val="101828"/>
+                </a:solidFill>
+              </a:rPr>
+              <a:t>Current</a:t>
+            </a:r>
+            <a:endParaRPr lang="en-US" sz="1200" dirty="0"/>
+          </a:p>
+          <a:p>
+            <a:pPr indent="0" marL="0">
+              <a:buNone/>
+            </a:pPr>
+            <a:r>
+              <a:rPr lang="en-US" sz="1200" dirty="0">
+                <a:solidFill>
+                  <a:srgbClr val="101828"/>
+                </a:solidFill>
+              </a:rPr>
+              <a:t>Delivery reliability</a:t>
+            </a:r>
+            <a:endParaRPr lang="en-US" sz="1200" dirty="0"/>
+          </a:p>
+          <a:p>
+            <a:pPr indent="0" marL="0">
+              <a:buNone/>
+            </a:pPr>
+            <a:r>
+              <a:rPr lang="en-US" sz="1200" dirty="0">
+                <a:solidFill>
+                  <a:srgbClr val="101828"/>
+                </a:solidFill>
+              </a:rPr>
+              <a:t>92%</a:t>
+            </a:r>
+            <a:endParaRPr lang="en-US" sz="1200" dirty="0"/>
+          </a:p>
+          <a:p>
+            <a:pPr indent="0" marL="0">
+              <a:buNone/>
+            </a:pPr>
+            <a:r>
+              <a:rPr lang="en-US" sz="1200" dirty="0">
+                <a:solidFill>
+                  <a:srgbClr val="101828"/>
+                </a:solidFill>
+              </a:rPr>
+              <a:t>Priority segments</a:t>
+            </a:r>
+            <a:endParaRPr lang="en-US" sz="1200" dirty="0"/>
+          </a:p>
+          <a:p>
+            <a:pPr indent="0" marL="0">
+              <a:buNone/>
+            </a:pPr>
+            <a:r>
+              <a:rPr lang="en-US" sz="1200" dirty="0">
+                <a:solidFill>
+                  <a:srgbClr val="101828"/>
+                </a:solidFill>
+              </a:rPr>
+              <a:t>2</a:t>
             </a:r>
             <a:endParaRPr lang="en-US" sz="1200" dirty="0"/>
           </a:p>
@@ -1634,7 +1718,7 @@
                   <a:srgbClr val="101828"/>
                 </a:solidFill>
               </a:rPr>
-              <a:t>The next four weeks prioritize throughput and evidence</a:t>
+              <a:t>The operating model is ready for a controlled next step.</a:t>
             </a:r>
             <a:endParaRPr lang="en-US" sz="1000" dirty="0"/>
           </a:p>
@@ -1693,7 +1777,7 @@
                   <a:srgbClr val="667085"/>
                 </a:solidFill>
               </a:rPr>
-              <a:t>Consultify · Northwind Traders · Internal</a:t>
+              <a:t>Consultify · Atelier Toys · Internal</a:t>
             </a:r>
             <a:endParaRPr lang="en-US" sz="650" dirty="0"/>
           </a:p>
@@ -1767,7 +1851,7 @@
                   <a:srgbClr val="667085"/>
                 </a:solidFill>
               </a:rPr>
-              <a:t>Source: Northwind steering snapshot</a:t>
+              <a:t>Source: Operating review</a:t>
             </a:r>
             <a:endParaRPr lang="en-US" sz="650" dirty="0"/>
           </a:p>
@@ -1873,7 +1957,7 @@
                   <a:srgbClr val="1B2A41"/>
                 </a:solidFill>
               </a:rPr>
-              <a:t>Approve the recovery sequence</a:t>
+              <a:t>Decision required</a:t>
             </a:r>
             <a:endParaRPr lang="en-US" sz="2100" dirty="0"/>
           </a:p>
@@ -2020,7 +2104,7 @@
                   <a:srgbClr val="1B2A41"/>
                 </a:solidFill>
               </a:rPr>
-              <a:t>Approve the four-week recovery sequence and review progress every Friday.</a:t>
+              <a:t>Start with the two priority segments and review after 30 days.</a:t>
             </a:r>
             <a:endParaRPr lang="en-US" sz="1100" dirty="0"/>
           </a:p>
@@ -2079,7 +2163,7 @@
                   <a:srgbClr val="667085"/>
                 </a:solidFill>
               </a:rPr>
-              <a:t>Consultify · Northwind Traders · Internal</a:t>
+              <a:t>Consultify · Atelier Toys · Internal</a:t>
             </a:r>
             <a:endParaRPr lang="en-US" sz="650" dirty="0"/>
           </a:p>
@@ -2153,7 +2237,7 @@
                   <a:srgbClr val="667085"/>
                 </a:solidFill>
               </a:rPr>
-              <a:t>Source: Northwind decision log</a:t>
+              <a:t>Source: Steering note</a:t>
             </a:r>
             <a:endParaRPr lang="en-US" sz="650" dirty="0"/>
           </a:p>

</xml_diff>